<commit_message>
590: replace stale ERAM, 2025 doc and Week 8 references in lectures
The lecture Markdown and the Lecture 1-4 and 7 PowerPoints now:
- say EPOL 590 instead of ERAM 590
- link the 2026 class document instead of the 2025 shared doc
- list Sessions 5-7 with dates in Lecture 4, not a "Week 8"
- give 1,500-2,000 words in Lecture 7 instead of 6-8 pages

ai-overview drops its "584 Lecture 0" title. The changed pages and the
sitemap are re-rendered.

Co-Authored-By: Claude Opus 5.5 <noreply@anthropic.com>
</commit_message>
<xml_diff>
--- a/courses/590-fall-2026/590-lecture-1.pptx
+++ b/courses/590-fall-2026/590-lecture-1.pptx
@@ -3134,7 +3134,8 @@
               <a:buNone/>
             </a:pPr>
             <a:r>
-              <a:t>ERAM 590 - AI and Academic Literature</a:t>
+              <a:rPr/>
+              <a:t>EPOL 590 - AI and Academic Literature</a:t>
             </a:r>
           </a:p>
         </p:txBody>
@@ -3193,24 +3194,28 @@
           <a:p>
             <a:pPr lvl="0"/>
             <a:r>
+              <a:rPr/>
               <a:t>“Industry” orientation: move fast and break things!</a:t>
             </a:r>
           </a:p>
           <a:p>
             <a:pPr lvl="0"/>
             <a:r>
+              <a:rPr/>
               <a:t>Quick sketches of a literature review - with AI (and caveats)</a:t>
             </a:r>
           </a:p>
           <a:p>
             <a:pPr lvl="0"/>
             <a:r>
+              <a:rPr/>
               <a:t>Why? The idea is to build intuitions about (a) how to review literature and (b) how to write-up those reviews quickly</a:t>
             </a:r>
           </a:p>
           <a:p>
             <a:pPr lvl="0"/>
             <a:r>
+              <a:rPr/>
               <a:t>Peer review: really more like turning an individual pursuit into something </a:t>
             </a:r>
             <a:r>
@@ -3218,6 +3223,7 @@
               <a:t>social</a:t>
             </a:r>
             <a:r>
+              <a:rPr/>
               <a:t>.</a:t>
             </a:r>
             <a:br/>
@@ -3226,18 +3232,21 @@
           <a:p>
             <a:pPr lvl="0"/>
             <a:r>
+              <a:rPr/>
               <a:t>AI Orientation:</a:t>
             </a:r>
           </a:p>
           <a:p>
             <a:pPr lvl="1"/>
             <a:r>
+              <a:rPr/>
               <a:t>Understanding that knowledge has always had a technical orientation (paper, printing press, media, computers, Internet)</a:t>
             </a:r>
           </a:p>
           <a:p>
             <a:pPr lvl="1"/>
             <a:r>
+              <a:rPr/>
               <a:t>But we need a critical lens; looking ahead to how technology should make us work harder intellectually (not easier)</a:t>
             </a:r>
           </a:p>
@@ -3297,42 +3306,49 @@
           <a:p>
             <a:pPr lvl="0"/>
             <a:r>
+              <a:rPr/>
               <a:t>We’ll use the 3 hours flexibly</a:t>
             </a:r>
           </a:p>
           <a:p>
             <a:pPr lvl="0"/>
             <a:r>
+              <a:rPr/>
               <a:t>2 x 10 minute breaks on the hour</a:t>
             </a:r>
           </a:p>
           <a:p>
             <a:pPr lvl="0"/>
             <a:r>
+              <a:rPr/>
               <a:t>The 3 hours will encompass (most of) the assessment</a:t>
             </a:r>
           </a:p>
           <a:p>
             <a:pPr lvl="0"/>
             <a:r>
+              <a:rPr/>
               <a:t>Mix of mini-lectures / discussion / group-work</a:t>
             </a:r>
           </a:p>
           <a:p>
             <a:pPr lvl="1"/>
             <a:r>
+              <a:rPr/>
               <a:t>With discussion - we’ll aim to build a lightweight notebook on good literature search / reading / review practices</a:t>
             </a:r>
           </a:p>
           <a:p>
             <a:pPr lvl="1"/>
             <a:r>
+              <a:rPr/>
               <a:t>AI exercises</a:t>
             </a:r>
           </a:p>
           <a:p>
             <a:pPr lvl="0"/>
             <a:r>
+              <a:rPr/>
               <a:t>Mix of theory / practice</a:t>
             </a:r>
           </a:p>
@@ -3392,12 +3408,14 @@
           <a:p>
             <a:pPr lvl="0"/>
             <a:r>
+              <a:rPr/>
               <a:t>What is Literature? What is a Literature Review?</a:t>
             </a:r>
           </a:p>
           <a:p>
             <a:pPr lvl="0"/>
             <a:r>
+              <a:rPr/>
               <a:t>What is Changing? How is AI Impacting Scholarship?</a:t>
             </a:r>
           </a:p>
@@ -3457,18 +3475,21 @@
           <a:p>
             <a:pPr lvl="0"/>
             <a:r>
+              <a:rPr/>
               <a:t>Encourage everyone to use some software (Obsidian etc)</a:t>
             </a:r>
           </a:p>
           <a:p>
             <a:pPr lvl="0"/>
             <a:r>
+              <a:rPr/>
               <a:t>Try to learn Markdown / Zettenkettel…</a:t>
             </a:r>
           </a:p>
           <a:p>
             <a:pPr lvl="0"/>
             <a:r>
+              <a:rPr/>
               <a:t>My own NightOwl - Why?</a:t>
             </a:r>
           </a:p>
@@ -3528,36 +3549,42 @@
           <a:p>
             <a:pPr lvl="0"/>
             <a:r>
+              <a:rPr/>
               <a:t>What we need:</a:t>
             </a:r>
           </a:p>
           <a:p>
             <a:pPr lvl="1"/>
             <a:r>
+              <a:rPr/>
               <a:t>A “continuous document”</a:t>
             </a:r>
           </a:p>
           <a:p>
             <a:pPr lvl="1"/>
             <a:r>
+              <a:rPr/>
               <a:t>Ability to share with peers &amp; annotate</a:t>
             </a:r>
           </a:p>
           <a:p>
             <a:pPr lvl="0"/>
             <a:r>
+              <a:rPr/>
               <a:t>Box / Microsoft Office? HIPAA-compliant but cumbersome</a:t>
             </a:r>
           </a:p>
           <a:p>
             <a:pPr lvl="0"/>
             <a:r>
+              <a:rPr/>
               <a:t>Canvas options?</a:t>
             </a:r>
           </a:p>
           <a:p>
             <a:pPr lvl="0"/>
             <a:r>
+              <a:rPr/>
               <a:t>Google Docs? Not HIPAA-compliant</a:t>
             </a:r>
           </a:p>
@@ -3567,7 +3594,7 @@
               <a:rPr>
                 <a:hlinkClick r:id="rId2"/>
               </a:rPr>
-              <a:t>ERAM 590 - Google Docs</a:t>
+              <a:t>EPOL 590 Fall 2026 class document</a:t>
             </a:r>
           </a:p>
         </p:txBody>
@@ -3634,6 +3661,7 @@
           <a:p>
             <a:pPr lvl="0"/>
             <a:r>
+              <a:rPr/>
               <a:t>Partly a question of </a:t>
             </a:r>
             <a:r>
@@ -3641,18 +3669,21 @@
               <a:t>feel</a:t>
             </a:r>
             <a:r>
+              <a:rPr/>
               <a:t> - experienced researchers know a good question when they see it</a:t>
             </a:r>
           </a:p>
           <a:p>
             <a:pPr lvl="0"/>
             <a:r>
+              <a:rPr/>
               <a:t>Sources:</a:t>
             </a:r>
           </a:p>
           <a:p>
             <a:pPr lvl="1"/>
             <a:r>
+              <a:rPr/>
               <a:t>Informed by </a:t>
             </a:r>
             <a:r>
@@ -3660,12 +3691,14 @@
               <a:t>literature</a:t>
             </a:r>
             <a:r>
+              <a:rPr/>
               <a:t>: what key problems are unsolved?</a:t>
             </a:r>
           </a:p>
           <a:p>
             <a:pPr lvl="1"/>
             <a:r>
+              <a:rPr/>
               <a:t>Informed by </a:t>
             </a:r>
             <a:r>
@@ -3673,12 +3706,14 @@
               <a:t>events</a:t>
             </a:r>
             <a:r>
+              <a:rPr/>
               <a:t>: what is happening and how do we explain it?</a:t>
             </a:r>
           </a:p>
           <a:p>
             <a:pPr lvl="1"/>
             <a:r>
+              <a:rPr/>
               <a:t>Informed by </a:t>
             </a:r>
             <a:r>
@@ -3686,12 +3721,14 @@
               <a:t>circumstance</a:t>
             </a:r>
             <a:r>
+              <a:rPr/>
               <a:t>: it annoys me no-one can answer this question - perhaps I can?</a:t>
             </a:r>
           </a:p>
           <a:p>
             <a:pPr lvl="1"/>
             <a:r>
+              <a:rPr/>
               <a:t>Informed by </a:t>
             </a:r>
             <a:r>
@@ -3699,12 +3736,14 @@
               <a:t>disposition</a:t>
             </a:r>
             <a:r>
+              <a:rPr/>
               <a:t>: I just love working on – or want to know more about – X.</a:t>
             </a:r>
           </a:p>
           <a:p>
             <a:pPr lvl="1"/>
             <a:r>
+              <a:rPr/>
               <a:t>Informed by </a:t>
             </a:r>
             <a:r>
@@ -3712,6 +3751,7 @@
               <a:t>sociality</a:t>
             </a:r>
             <a:r>
+              <a:rPr/>
               <a:t> (FOMO): All the cool kids work on X - should I be working on it too? Or should I </a:t>
             </a:r>
             <a:r>
@@ -3719,6 +3759,7 @@
               <a:t>not</a:t>
             </a:r>
             <a:r>
+              <a:rPr/>
               <a:t> be working on it?</a:t>
             </a:r>
           </a:p>
@@ -3778,12 +3819,14 @@
           <a:p>
             <a:pPr lvl="0"/>
             <a:r>
+              <a:rPr/>
               <a:t>Should I dream up a research question from thin air? Should I wait until I’ve done a systematic literature review?</a:t>
             </a:r>
           </a:p>
           <a:p>
             <a:pPr lvl="0"/>
             <a:r>
+              <a:rPr/>
               <a:t>Think of the relationship between research question and literature review as </a:t>
             </a:r>
             <a:r>
@@ -3791,18 +3834,21 @@
               <a:t>dialectical</a:t>
             </a:r>
             <a:r>
+              <a:rPr/>
               <a:t> (each directing the other):</a:t>
             </a:r>
           </a:p>
           <a:p>
             <a:pPr lvl="1"/>
             <a:r>
+              <a:rPr/>
               <a:t>Think of a draft topic / question</a:t>
             </a:r>
           </a:p>
           <a:p>
             <a:pPr lvl="1"/>
             <a:r>
+              <a:rPr/>
               <a:t>Search on the topic / question. Is it answered? Wholly or partly? Which parts remain?</a:t>
             </a:r>
           </a:p>
@@ -3862,6 +3908,7 @@
               <a:buNone/>
             </a:pPr>
             <a:r>
+              <a:rPr/>
               <a:t>Image</a:t>
             </a:r>
           </a:p>
@@ -3921,6 +3968,7 @@
           <a:p>
             <a:pPr lvl="0"/>
             <a:r>
+              <a:rPr/>
               <a:t>Does the research question </a:t>
             </a:r>
             <a:r>
@@ -3928,6 +3976,7 @@
               <a:t>need an answer</a:t>
             </a:r>
             <a:r>
+              <a:rPr/>
               <a:t>? Is it </a:t>
             </a:r>
             <a:r>
@@ -3935,12 +3984,14 @@
               <a:t>necessary</a:t>
             </a:r>
             <a:r>
+              <a:rPr/>
               <a:t>? Or does it provoke a “so what?” response?</a:t>
             </a:r>
           </a:p>
           <a:p>
             <a:pPr lvl="0"/>
             <a:r>
+              <a:rPr/>
               <a:t>Is it </a:t>
             </a:r>
             <a:r>
@@ -3948,6 +3999,7 @@
               <a:t>doable</a:t>
             </a:r>
             <a:r>
+              <a:rPr/>
               <a:t> and </a:t>
             </a:r>
             <a:r>
@@ -3955,12 +4007,14 @@
               <a:t>feasible</a:t>
             </a:r>
             <a:r>
+              <a:rPr/>
               <a:t>? Or would I need 100 years / 1 billion dollars / a vast research team to do it?</a:t>
             </a:r>
           </a:p>
           <a:p>
             <a:pPr lvl="0"/>
             <a:r>
+              <a:rPr/>
               <a:t>Will I be able to answer this question with </a:t>
             </a:r>
             <a:r>
@@ -3968,6 +4022,7 @@
               <a:t>methods</a:t>
             </a:r>
             <a:r>
+              <a:rPr/>
               <a:t> that I know and </a:t>
             </a:r>
             <a:r>
@@ -3975,6 +4030,7 @@
               <a:t>data</a:t>
             </a:r>
             <a:r>
+              <a:rPr/>
               <a:t> that I can access?</a:t>
             </a:r>
           </a:p>
@@ -4034,18 +4090,21 @@
           <a:p>
             <a:pPr lvl="0"/>
             <a:r>
+              <a:rPr/>
               <a:t>Has this question been answered before?</a:t>
             </a:r>
           </a:p>
           <a:p>
             <a:pPr lvl="1"/>
             <a:r>
+              <a:rPr/>
               <a:t>Not always obvious… Many different literatures, disciplines, traditions work on related problems.</a:t>
             </a:r>
           </a:p>
           <a:p>
             <a:pPr lvl="0"/>
             <a:r>
+              <a:rPr/>
               <a:t>Is it </a:t>
             </a:r>
             <a:r>
@@ -4053,12 +4112,14 @@
               <a:t>novel</a:t>
             </a:r>
             <a:r>
+              <a:rPr/>
               <a:t> for good reasons? No one needs an answer to it, or it is unanswerable through research (does God exist?)</a:t>
             </a:r>
           </a:p>
           <a:p>
             <a:pPr lvl="0"/>
             <a:r>
+              <a:rPr/>
               <a:t>Is it likely to remain novel throughout my research? Think of AI: “No one has studied the impact of Gemini 3 / ChatGPT 6 on student learning” (because these systems aren’t released yet - but once they are, the studies will follow).</a:t>
             </a:r>
           </a:p>
@@ -4118,12 +4179,14 @@
           <a:p>
             <a:pPr lvl="0"/>
             <a:r>
+              <a:rPr/>
               <a:t>What happens when I know the results</a:t>
             </a:r>
           </a:p>
           <a:p>
             <a:pPr lvl="0"/>
             <a:r>
+              <a:rPr/>
               <a:t>Is it </a:t>
             </a:r>
             <a:r>
@@ -4131,6 +4194,7 @@
               <a:t>doable</a:t>
             </a:r>
             <a:r>
+              <a:rPr/>
               <a:t> and </a:t>
             </a:r>
             <a:r>
@@ -4138,12 +4202,14 @@
               <a:t>feasible</a:t>
             </a:r>
             <a:r>
+              <a:rPr/>
               <a:t>? Or would I need 100 years / 1 billion dollars / a vast research team to do it?</a:t>
             </a:r>
           </a:p>
           <a:p>
             <a:pPr lvl="0"/>
             <a:r>
+              <a:rPr/>
               <a:t>Will I be able to answer this question with </a:t>
             </a:r>
             <a:r>
@@ -4151,6 +4217,7 @@
               <a:t>methods</a:t>
             </a:r>
             <a:r>
+              <a:rPr/>
               <a:t> that I know and </a:t>
             </a:r>
             <a:r>
@@ -4158,6 +4225,7 @@
               <a:t>data</a:t>
             </a:r>
             <a:r>
+              <a:rPr/>
               <a:t> that I can access?</a:t>
             </a:r>
           </a:p>
@@ -4207,6 +4275,7 @@
               <a:buNone/>
             </a:pPr>
             <a:r>
+              <a:rPr/>
               <a:t>Lecture 1</a:t>
             </a:r>
           </a:p>
@@ -4266,24 +4335,28 @@
           <a:p>
             <a:pPr lvl="0"/>
             <a:r>
+              <a:rPr/>
               <a:t>We’ll all need a candidate research question / topic</a:t>
             </a:r>
           </a:p>
           <a:p>
             <a:pPr lvl="0"/>
             <a:r>
+              <a:rPr/>
               <a:t>Doesn’t need to be your dissertation!</a:t>
             </a:r>
           </a:p>
           <a:p>
             <a:pPr lvl="0"/>
             <a:r>
+              <a:rPr/>
               <a:t>Breakout groups: work on a pseudo-topic</a:t>
             </a:r>
           </a:p>
           <a:p>
             <a:pPr lvl="0"/>
             <a:r>
+              <a:rPr/>
               <a:t>Document the topic!</a:t>
             </a:r>
           </a:p>
@@ -4345,6 +4418,7 @@
               <a:buNone/>
             </a:pPr>
             <a:r>
+              <a:rPr/>
               <a:t>Weber, M. (1946). Science as a Vocation. In Science and the Quest for Reality (pp. 382-394). London: Palgrave Macmillan UK.</a:t>
             </a:r>
           </a:p>
@@ -4353,6 +4427,7 @@
               <a:buNone/>
             </a:pPr>
             <a:r>
+              <a:rPr/>
               <a:t>libguides.umn.edu. n.d. “Characteristics of a Good Research Question - Literature Searching - Research Guides at University of Minnesota Minneapolis.” Libguides.umn.edu. [https://libguides.umn.edu/c.php?g=1337354&amp;p=9854773].</a:t>
             </a:r>
           </a:p>
@@ -4412,24 +4487,28 @@
           <a:p>
             <a:pPr lvl="0"/>
             <a:r>
+              <a:rPr/>
               <a:t>What is this course about? Do we need another course on academic literature?</a:t>
             </a:r>
           </a:p>
           <a:p>
             <a:pPr lvl="0"/>
             <a:r>
+              <a:rPr/>
               <a:t>Foundational: How to Develop a Literature Review</a:t>
             </a:r>
           </a:p>
           <a:p>
             <a:pPr lvl="0"/>
             <a:r>
+              <a:rPr/>
               <a:t>Future-Oriented: How AI is Impacting Academic Literature / Scholarship</a:t>
             </a:r>
           </a:p>
           <a:p>
             <a:pPr lvl="0"/>
             <a:r>
+              <a:rPr/>
               <a:t>Mix of Theory and Practice</a:t>
             </a:r>
           </a:p>
@@ -4491,6 +4570,7 @@
               <a:buNone/>
             </a:pPr>
             <a:r>
+              <a:rPr/>
               <a:t>How do you build a sense of your field and its gaps? This course aims to make sense of a term – academic literature – at once mundane and mystical. It starts with fundamentals: how to build, annotate, analyze, map and translate a literature database into a literature review. It progresses to think about how AI and other technology can help foster more critical, analytic and reflexive modes of interpretation and understandings of the field.</a:t>
             </a:r>
           </a:p>
@@ -4499,6 +4579,7 @@
               <a:buNone/>
             </a:pPr>
             <a:r>
+              <a:rPr/>
               <a:t>All required material (video lectures, readings etc.) will be provided to students.</a:t>
             </a:r>
           </a:p>
@@ -4558,42 +4639,49 @@
           <a:p>
             <a:pPr lvl="0"/>
             <a:r>
+              <a:rPr/>
               <a:t>Week 1 - Course Overview / What’s a Good Research Question? / AI tools for literature</a:t>
             </a:r>
           </a:p>
           <a:p>
             <a:pPr lvl="0"/>
             <a:r>
+              <a:rPr/>
               <a:t>Week 2 - Where’s the Gap? Mapping a Field / Anatomy of a Journal Article</a:t>
             </a:r>
           </a:p>
           <a:p>
             <a:pPr lvl="0"/>
             <a:r>
+              <a:rPr/>
               <a:t>Week 3 - Does Artificial Intelligence mean Artificial Knowledge? How AI is Impacting Academia / Vibe Scholarship (Is It as Bad as It Sounds?)</a:t>
             </a:r>
           </a:p>
           <a:p>
             <a:pPr lvl="0"/>
             <a:r>
+              <a:rPr/>
               <a:t>Week 4 - Academic Audiences and Techniques of Persuasion / Finding Your Scholarly Voice: Peers / Audience / Venue / Field</a:t>
             </a:r>
           </a:p>
           <a:p>
             <a:pPr lvl="0"/>
             <a:r>
+              <a:rPr/>
               <a:t>Week 5 - “What Do I Know?” Towards A Sociology of Knowledge / Designing a Literature Review</a:t>
             </a:r>
           </a:p>
           <a:p>
             <a:pPr lvl="0"/>
             <a:r>
+              <a:rPr/>
               <a:t>Week 6 - The Reflexive Researcher</a:t>
             </a:r>
           </a:p>
           <a:p>
             <a:pPr lvl="0"/>
             <a:r>
+              <a:rPr/>
               <a:t>Week 7 - The Automatic Academy? The Future of Scholarship</a:t>
             </a:r>
           </a:p>
@@ -4655,6 +4743,7 @@
               <a:buNone/>
             </a:pPr>
             <a:r>
+              <a:rPr/>
               <a:t>The aim of the course is to build a </a:t>
             </a:r>
             <a:r>
@@ -4662,6 +4751,7 @@
               <a:t>cumulative</a:t>
             </a:r>
             <a:r>
+              <a:rPr/>
               <a:t> literature review. It is a course in which to experiment with different approaches to engage with literature. Accordingly assessment will focus less on the “correctness” of the final output and more on week-to-week engagement with course materials and activities.</a:t>
             </a:r>
           </a:p>
@@ -4670,6 +4760,7 @@
               <a:buNone/>
             </a:pPr>
             <a:r>
+              <a:rPr/>
               <a:t>That all said, the purpose of the course is to support a dissertation / journal article / other academic writing – to that extent, if the final output does serve other purposes, well and good!</a:t>
             </a:r>
           </a:p>
@@ -4729,42 +4820,49 @@
           <a:p>
             <a:pPr lvl="0"/>
             <a:r>
+              <a:rPr/>
               <a:t>Week 1: First Draft of Research Topic / Research Question (10%)</a:t>
             </a:r>
           </a:p>
           <a:p>
             <a:pPr lvl="0"/>
             <a:r>
+              <a:rPr/>
               <a:t>Week 2: Design, Method and Structure of the Literature Review (10%)</a:t>
             </a:r>
           </a:p>
           <a:p>
             <a:pPr lvl="0"/>
             <a:r>
+              <a:rPr/>
               <a:t>Week 3: Concept Map of the Literature (10%)</a:t>
             </a:r>
           </a:p>
           <a:p>
             <a:pPr lvl="0"/>
             <a:r>
+              <a:rPr/>
               <a:t>Week 4: Literature Review Sample: In the Scientific Mode / In the Humanities Mode (10%)</a:t>
             </a:r>
           </a:p>
           <a:p>
             <a:pPr lvl="0"/>
             <a:r>
+              <a:rPr/>
               <a:t>Week 5: Literature Review: Signposting (10%)</a:t>
             </a:r>
           </a:p>
           <a:p>
             <a:pPr lvl="0"/>
             <a:r>
+              <a:rPr/>
               <a:t>Week 6: Statement about the use of AI in your Literature Review / Reflection about the role of AI in academia (10%)</a:t>
             </a:r>
           </a:p>
           <a:p>
             <a:pPr lvl="0"/>
             <a:r>
+              <a:rPr/>
               <a:t>Week 7: Final Literature Review (40%) - </a:t>
             </a:r>
             <a:r>
@@ -4946,6 +5044,7 @@
                         <a:buNone/>
                       </a:pPr>
                       <a:r>
+                        <a:rPr/>
                         <a:t>Course Overview / Anatomy of a Journal Article / What Makes a Good Research Question?</a:t>
                       </a:r>
                     </a:p>
@@ -4961,6 +5060,7 @@
                         <a:buNone/>
                       </a:pPr>
                       <a:r>
+                        <a:rPr/>
                         <a:t>AI Tools for Literature</a:t>
                       </a:r>
                     </a:p>
@@ -4976,6 +5076,7 @@
                         <a:buNone/>
                       </a:pPr>
                       <a:r>
+                        <a:rPr/>
                         <a:t>First Draft of Research Topic / Research Question</a:t>
                       </a:r>
                     </a:p>
@@ -5014,6 +5115,7 @@
                         <a:buNone/>
                       </a:pPr>
                       <a:r>
+                        <a:rPr/>
                         <a:t>Academic Audiences and Techniques of Persuasion</a:t>
                       </a:r>
                     </a:p>
@@ -5029,6 +5131,7 @@
                         <a:buNone/>
                       </a:pPr>
                       <a:r>
+                        <a:rPr/>
                         <a:t>Where’s the Gap? Mapping a Field</a:t>
                       </a:r>
                     </a:p>
@@ -5044,6 +5147,7 @@
                         <a:buNone/>
                       </a:pPr>
                       <a:r>
+                        <a:rPr/>
                         <a:t>Design, Method and Structure of the Literature Review</a:t>
                       </a:r>
                     </a:p>
@@ -5082,6 +5186,7 @@
                         <a:buNone/>
                       </a:pPr>
                       <a:r>
+                        <a:rPr/>
                         <a:t>Does Artificial Intelligence Mean Artificial Knowledge? How AI is Impacting Academia</a:t>
                       </a:r>
                     </a:p>
@@ -5097,6 +5202,7 @@
                         <a:buNone/>
                       </a:pPr>
                       <a:r>
+                        <a:rPr/>
                         <a:t>Vibe Scholarship (Is It as Bad as It Sounds?)</a:t>
                       </a:r>
                     </a:p>
@@ -5112,6 +5218,7 @@
                         <a:buNone/>
                       </a:pPr>
                       <a:r>
+                        <a:rPr/>
                         <a:t>Concept Map of the Literature</a:t>
                       </a:r>
                     </a:p>
@@ -5150,6 +5257,7 @@
                         <a:buNone/>
                       </a:pPr>
                       <a:r>
+                        <a:rPr/>
                         <a:t>Finding Your Scholarly Voice: Peers / Audience / Venue / Field</a:t>
                       </a:r>
                     </a:p>
@@ -5165,6 +5273,7 @@
                         <a:buNone/>
                       </a:pPr>
                       <a:r>
+                        <a:rPr/>
                         <a:t>Drafting a section of your review in a </a:t>
                       </a:r>
                       <a:r>
@@ -5172,6 +5281,7 @@
                         <a:t>scientific</a:t>
                       </a:r>
                       <a:r>
+                        <a:rPr/>
                         <a:t> and </a:t>
                       </a:r>
                       <a:r>
@@ -5179,6 +5289,7 @@
                         <a:t>humanities</a:t>
                       </a:r>
                       <a:r>
+                        <a:rPr/>
                         <a:t> mode</a:t>
                       </a:r>
                     </a:p>
@@ -5194,6 +5305,7 @@
                         <a:buNone/>
                       </a:pPr>
                       <a:r>
+                        <a:rPr/>
                         <a:t>Literature Review Sample: In the Scientific Mode</a:t>
                       </a:r>
                     </a:p>
@@ -5232,6 +5344,7 @@
                         <a:buNone/>
                       </a:pPr>
                       <a:r>
+                        <a:rPr/>
                         <a:t>“What Do I Know?” Towards A Sociology of Knowledge</a:t>
                       </a:r>
                     </a:p>
@@ -5247,6 +5360,7 @@
                         <a:buNone/>
                       </a:pPr>
                       <a:r>
+                        <a:rPr/>
                         <a:t>Framing Language: “Carry” Your Reader</a:t>
                       </a:r>
                     </a:p>
@@ -5262,6 +5376,7 @@
                         <a:buNone/>
                       </a:pPr>
                       <a:r>
+                        <a:rPr/>
                         <a:t>Frame up your Literature Review</a:t>
                       </a:r>
                     </a:p>
@@ -5300,6 +5415,7 @@
                         <a:buNone/>
                       </a:pPr>
                       <a:r>
+                        <a:rPr/>
                         <a:t>The Reflexive Researcher and Interpreting Scholarship</a:t>
                       </a:r>
                     </a:p>
@@ -5315,6 +5431,7 @@
                         <a:buNone/>
                       </a:pPr>
                       <a:r>
+                        <a:rPr/>
                         <a:t>Reflecting on your positionality vis-a-vis interpretation; drafting a statement about AI’s epistemic role</a:t>
                       </a:r>
                     </a:p>
@@ -5330,6 +5447,7 @@
                         <a:buNone/>
                       </a:pPr>
                       <a:r>
+                        <a:rPr/>
                         <a:t>Statement on the Use of AI in Your Literature Review / Reflection on the Role of AI in Academia</a:t>
                       </a:r>
                     </a:p>
@@ -5368,6 +5486,7 @@
                         <a:buNone/>
                       </a:pPr>
                       <a:r>
+                        <a:rPr/>
                         <a:t>The Automatic Academy? The Future of Scholarship</a:t>
                       </a:r>
                     </a:p>
@@ -5383,6 +5502,7 @@
                         <a:buNone/>
                       </a:pPr>
                       <a:r>
+                        <a:rPr/>
                         <a:t>Compiling a complete literature review</a:t>
                       </a:r>
                     </a:p>
@@ -5473,6 +5593,7 @@
               <a:t>Develop</a:t>
             </a:r>
             <a:r>
+              <a:rPr/>
               <a:t> novel, significant and feasible research question</a:t>
             </a:r>
           </a:p>
@@ -5483,6 +5604,7 @@
               <a:t>Compile</a:t>
             </a:r>
             <a:r>
+              <a:rPr/>
               <a:t> relevant map of the field relating to the research question</a:t>
             </a:r>
           </a:p>
@@ -5493,6 +5615,7 @@
               <a:t>Choose</a:t>
             </a:r>
             <a:r>
+              <a:rPr/>
               <a:t> and </a:t>
             </a:r>
             <a:r>
@@ -5500,6 +5623,7 @@
               <a:t>apply</a:t>
             </a:r>
             <a:r>
+              <a:rPr/>
               <a:t> appropriate citation practices (science / humanities / mix) for question &amp; field</a:t>
             </a:r>
           </a:p>
@@ -5510,6 +5634,7 @@
               <a:t>Use</a:t>
             </a:r>
             <a:r>
+              <a:rPr/>
               <a:t> framing / signposting / metadiscursive language</a:t>
             </a:r>
           </a:p>
@@ -5520,6 +5645,7 @@
               <a:t>Show</a:t>
             </a:r>
             <a:r>
+              <a:rPr/>
               <a:t> reflexivity as a scholar</a:t>
             </a:r>
           </a:p>
@@ -5530,6 +5656,7 @@
               <a:t>Acknowledge</a:t>
             </a:r>
             <a:r>
+              <a:rPr/>
               <a:t> and </a:t>
             </a:r>
             <a:r>
@@ -5537,12 +5664,14 @@
               <a:t>demonstrate</a:t>
             </a:r>
             <a:r>
+              <a:rPr/>
               <a:t> appropriate use of AI</a:t>
             </a:r>
           </a:p>
           <a:p>
             <a:pPr lvl="0"/>
             <a:r>
+              <a:rPr/>
               <a:t>Use all of the above to </a:t>
             </a:r>
             <a:r>
@@ -5550,6 +5679,7 @@
               <a:t>highlight</a:t>
             </a:r>
             <a:r>
+              <a:rPr/>
               <a:t> a plausible gap in the literature</a:t>
             </a:r>
           </a:p>

</xml_diff>

<commit_message>
590: keep only lecture-sourced readings; align Lecture 1; move planning docs to drafts
Readings: the syllabus, the Word syllabus and Canvas now list only the
readings already in the lecture materials. Sessions 5-7 go back to "to
be selected". The annotated draft with added suggestions is removed.

Syllabus: restore the missing commas in the schedule's focus column,
and rename Task 6's heading to its Canvas name.

Lecture 1: the Markdown and PowerPoint now show the 2026 sessions with
dates, the Canvas task names and due dates, and the six syllabus
criteria. The duplicate "Consequences" slide and section are removed.

canvas-setup.md and desktop-handoff.md are instructor planning notes,
so they move to _drafts/. canvas-setup.html comes off the public site,
and the sitemap is regenerated.

Co-Authored-By: Claude Opus 5.5 <noreply@anthropic.com>
</commit_message>
<xml_diff>
--- a/courses/590-fall-2026/590-lecture-1.pptx
+++ b/courses/590-fall-2026/590-lecture-1.pptx
@@ -23,7 +23,6 @@
     <p:sldId id="271" r:id="rId17"/>
     <p:sldId id="272" r:id="rId18"/>
     <p:sldId id="273" r:id="rId19"/>
-    <p:sldId id="274" r:id="rId20"/>
     <p:sldId id="275" r:id="rId21"/>
     <p:sldId id="276" r:id="rId22"/>
   </p:sldIdLst>
@@ -4133,112 +4132,6 @@
 </p:sld>
 </file>
 
-<file path=ppt/slides/slide19.xml><?xml version="1.0" encoding="utf-8"?>
-<p:sld xmlns:a="http://schemas.openxmlformats.org/drawingml/2006/main" xmlns:r="http://schemas.openxmlformats.org/officeDocument/2006/relationships" xmlns:p="http://schemas.openxmlformats.org/presentationml/2006/main">
-  <p:cSld>
-    <p:spTree>
-      <p:nvGrpSpPr>
-        <p:cNvPr id="1" name=""/>
-        <p:cNvGrpSpPr/>
-        <p:nvPr/>
-      </p:nvGrpSpPr>
-      <p:grpSpPr>
-        <a:xfrm>
-          <a:off x="0" y="0"/>
-          <a:ext cx="0" cy="0"/>
-          <a:chOff x="0" y="0"/>
-          <a:chExt cx="0" cy="0"/>
-        </a:xfrm>
-      </p:grpSpPr>
-      <p:sp>
-        <p:nvSpPr>
-          <p:cNvPr id="3" name="Content Placeholder 2"/>
-          <p:cNvSpPr>
-            <a:spLocks noGrp="1"/>
-          </p:cNvSpPr>
-          <p:nvPr>
-            <p:ph idx="1"/>
-          </p:nvPr>
-        </p:nvSpPr>
-        <p:spPr/>
-        <p:txBody>
-          <a:bodyPr/>
-          <a:lstStyle/>
-          <a:p>
-            <a:pPr marL="0" lvl="0" indent="0">
-              <a:spcBef>
-                <a:spcPts val="3000"/>
-              </a:spcBef>
-              <a:buNone/>
-            </a:pPr>
-            <a:r>
-              <a:rPr b="1"/>
-              <a:t>What Makes a Good Research Question? Consequences</a:t>
-            </a:r>
-          </a:p>
-          <a:p>
-            <a:pPr lvl="0"/>
-            <a:r>
-              <a:rPr/>
-              <a:t>What happens when I know the results</a:t>
-            </a:r>
-          </a:p>
-          <a:p>
-            <a:pPr lvl="0"/>
-            <a:r>
-              <a:rPr/>
-              <a:t>Is it </a:t>
-            </a:r>
-            <a:r>
-              <a:rPr i="1"/>
-              <a:t>doable</a:t>
-            </a:r>
-            <a:r>
-              <a:rPr/>
-              <a:t> and </a:t>
-            </a:r>
-            <a:r>
-              <a:rPr i="1"/>
-              <a:t>feasible</a:t>
-            </a:r>
-            <a:r>
-              <a:rPr/>
-              <a:t>? Or would I need 100 years / 1 billion dollars / a vast research team to do it?</a:t>
-            </a:r>
-          </a:p>
-          <a:p>
-            <a:pPr lvl="0"/>
-            <a:r>
-              <a:rPr/>
-              <a:t>Will I be able to answer this question with </a:t>
-            </a:r>
-            <a:r>
-              <a:rPr i="1"/>
-              <a:t>methods</a:t>
-            </a:r>
-            <a:r>
-              <a:rPr/>
-              <a:t> that I know and </a:t>
-            </a:r>
-            <a:r>
-              <a:rPr i="1"/>
-              <a:t>data</a:t>
-            </a:r>
-            <a:r>
-              <a:rPr/>
-              <a:t> that I can access?</a:t>
-            </a:r>
-          </a:p>
-        </p:txBody>
-      </p:sp>
-    </p:spTree>
-  </p:cSld>
-  <p:clrMapOvr>
-    <a:masterClrMapping/>
-  </p:clrMapOvr>
-</p:sld>
-</file>
-
 <file path=ppt/slides/slide2.xml><?xml version="1.0" encoding="utf-8"?>
 <p:sld xmlns:a="http://schemas.openxmlformats.org/drawingml/2006/main" xmlns:r="http://schemas.openxmlformats.org/officeDocument/2006/relationships" xmlns:p="http://schemas.openxmlformats.org/presentationml/2006/main">
   <p:cSld>
@@ -4640,49 +4533,49 @@
             <a:pPr lvl="0"/>
             <a:r>
               <a:rPr/>
-              <a:t>Week 1 - Course Overview / What’s a Good Research Question? / AI tools for literature</a:t>
-            </a:r>
-          </a:p>
-          <a:p>
-            <a:pPr lvl="0"/>
-            <a:r>
-              <a:rPr/>
-              <a:t>Week 2 - Where’s the Gap? Mapping a Field / Anatomy of a Journal Article</a:t>
-            </a:r>
-          </a:p>
-          <a:p>
-            <a:pPr lvl="0"/>
-            <a:r>
-              <a:rPr/>
-              <a:t>Week 3 - Does Artificial Intelligence mean Artificial Knowledge? How AI is Impacting Academia / Vibe Scholarship (Is It as Bad as It Sounds?)</a:t>
-            </a:r>
-          </a:p>
-          <a:p>
-            <a:pPr lvl="0"/>
-            <a:r>
-              <a:rPr/>
-              <a:t>Week 4 - Academic Audiences and Techniques of Persuasion / Finding Your Scholarly Voice: Peers / Audience / Venue / Field</a:t>
-            </a:r>
-          </a:p>
-          <a:p>
-            <a:pPr lvl="0"/>
-            <a:r>
-              <a:rPr/>
-              <a:t>Week 5 - “What Do I Know?” Towards A Sociology of Knowledge / Designing a Literature Review</a:t>
-            </a:r>
-          </a:p>
-          <a:p>
-            <a:pPr lvl="0"/>
-            <a:r>
-              <a:rPr/>
-              <a:t>Week 6 - The Reflexive Researcher</a:t>
-            </a:r>
-          </a:p>
-          <a:p>
-            <a:pPr lvl="0"/>
-            <a:r>
-              <a:rPr/>
-              <a:t>Week 7 - The Automatic Academy? The Future of Scholarship</a:t>
+              <a:t>Session 1 (Oct 19) – Research questions and academic literature</a:t>
+            </a:r>
+          </a:p>
+          <a:p>
+            <a:pPr lvl="0"/>
+            <a:r>
+              <a:rPr/>
+              <a:t>Session 2 (Oct 26) – Article anatomy, review design and mapping a field</a:t>
+            </a:r>
+          </a:p>
+          <a:p>
+            <a:pPr lvl="0"/>
+            <a:r>
+              <a:rPr/>
+              <a:t>Session 3 (Nov 2) – AI-assisted close and distant reading</a:t>
+            </a:r>
+          </a:p>
+          <a:p>
+            <a:pPr lvl="0"/>
+            <a:r>
+              <a:rPr/>
+              <a:t>Session 4 (Nov 9) – Difficult texts, audiences and scholarly voice</a:t>
+            </a:r>
+          </a:p>
+          <a:p>
+            <a:pPr lvl="0"/>
+            <a:r>
+              <a:rPr/>
+              <a:t>Session 5 (Nov 16) – Structure, signposting and scholarly communities</a:t>
+            </a:r>
+          </a:p>
+          <a:p>
+            <a:pPr lvl="0"/>
+            <a:r>
+              <a:rPr/>
+              <a:t>Session 6 (Nov 30) – Reflexivity, positionality and AI in scholarship (no seminar Nov 23)</a:t>
+            </a:r>
+          </a:p>
+          <a:p>
+            <a:pPr lvl="0"/>
+            <a:r>
+              <a:rPr/>
+              <a:t>Session 7 (Dec 7) – The future of scholarship and final review workshop</a:t>
             </a:r>
           </a:p>
         </p:txBody>
@@ -4821,53 +4714,53 @@
             <a:pPr lvl="0"/>
             <a:r>
               <a:rPr/>
-              <a:t>Week 1: First Draft of Research Topic / Research Question (10%)</a:t>
-            </a:r>
-          </a:p>
-          <a:p>
-            <a:pPr lvl="0"/>
-            <a:r>
-              <a:rPr/>
-              <a:t>Week 2: Design, Method and Structure of the Literature Review (10%)</a:t>
-            </a:r>
-          </a:p>
-          <a:p>
-            <a:pPr lvl="0"/>
-            <a:r>
-              <a:rPr/>
-              <a:t>Week 3: Concept Map of the Literature (10%)</a:t>
-            </a:r>
-          </a:p>
-          <a:p>
-            <a:pPr lvl="0"/>
-            <a:r>
-              <a:rPr/>
-              <a:t>Week 4: Literature Review Sample: In the Scientific Mode / In the Humanities Mode (10%)</a:t>
-            </a:r>
-          </a:p>
-          <a:p>
-            <a:pPr lvl="0"/>
-            <a:r>
-              <a:rPr/>
-              <a:t>Week 5: Literature Review: Signposting (10%)</a:t>
-            </a:r>
-          </a:p>
-          <a:p>
-            <a:pPr lvl="0"/>
-            <a:r>
-              <a:rPr/>
-              <a:t>Week 6: Statement about the use of AI in your Literature Review / Reflection about the role of AI in academia (10%)</a:t>
-            </a:r>
-          </a:p>
-          <a:p>
-            <a:pPr lvl="0"/>
-            <a:r>
-              <a:rPr/>
-              <a:t>Week 7: Final Literature Review (40%) - </a:t>
+              <a:t>1 Research topic and question (10%) – Fri Oct 23</a:t>
+            </a:r>
+          </a:p>
+          <a:p>
+            <a:pPr lvl="0"/>
+            <a:r>
+              <a:rPr/>
+              <a:t>2 Review design method and scope (10%) – Fri Oct 30</a:t>
+            </a:r>
+          </a:p>
+          <a:p>
+            <a:pPr lvl="0"/>
+            <a:r>
+              <a:rPr/>
+              <a:t>3 Conceptual map of the literature (10%) – Fri Nov 6</a:t>
+            </a:r>
+          </a:p>
+          <a:p>
+            <a:pPr lvl="0"/>
+            <a:r>
+              <a:rPr/>
+              <a:t>4 Literature review writing sample (10%) – Fri Nov 13</a:t>
+            </a:r>
+          </a:p>
+          <a:p>
+            <a:pPr lvl="0"/>
+            <a:r>
+              <a:rPr/>
+              <a:t>5 Structured draft and signposting (10%) – Fri Nov 20</a:t>
+            </a:r>
+          </a:p>
+          <a:p>
+            <a:pPr lvl="0"/>
+            <a:r>
+              <a:rPr/>
+              <a:t>6 AI-use statement and reflexive commentary (10%) – Fri Dec 4</a:t>
+            </a:r>
+          </a:p>
+          <a:p>
+            <a:pPr lvl="0"/>
+            <a:r>
+              <a:rPr/>
+              <a:t>7 Final literature review (40%) – Due Tuesday Dec 15, 2026, 11:59 PM Central; 1,500–2,000 words</a:t>
             </a:r>
             <a:r>
               <a:rPr b="1"/>
-              <a:t>Due Tuesday Dec 15, 2026, 11:59 PM Central</a:t>
+              <a:t/>
             </a:r>
           </a:p>
         </p:txBody>
@@ -4958,7 +4851,7 @@
                       </a:pPr>
                       <a:r>
                         <a:rPr b="1"/>
-                        <a:t>Week</a:t>
+                        <a:t>Session</a:t>
                       </a:r>
                     </a:p>
                   </a:txBody>
@@ -4974,7 +4867,7 @@
                       </a:pPr>
                       <a:r>
                         <a:rPr b="1"/>
-                        <a:t>Theory</a:t>
+                        <a:t>Seminar</a:t>
                       </a:r>
                     </a:p>
                   </a:txBody>
@@ -4990,7 +4883,7 @@
                       </a:pPr>
                       <a:r>
                         <a:rPr b="1"/>
-                        <a:t>Practice</a:t>
+                        <a:t>Focus</a:t>
                       </a:r>
                     </a:p>
                   </a:txBody>
@@ -5006,7 +4899,7 @@
                       </a:pPr>
                       <a:r>
                         <a:rPr b="1"/>
-                        <a:t>Assessment</a:t>
+                        <a:t>Task due</a:t>
                       </a:r>
                     </a:p>
                   </a:txBody>
@@ -5045,7 +4938,7 @@
                       </a:pPr>
                       <a:r>
                         <a:rPr/>
-                        <a:t>Course Overview / Anatomy of a Journal Article / What Makes a Good Research Question?</a:t>
+                        <a:t>Oct 19</a:t>
                       </a:r>
                     </a:p>
                   </a:txBody>
@@ -5061,7 +4954,7 @@
                       </a:pPr>
                       <a:r>
                         <a:rPr/>
-                        <a:t>AI Tools for Literature</a:t>
+                        <a:t>Research questions and academic literature</a:t>
                       </a:r>
                     </a:p>
                   </a:txBody>
@@ -5077,7 +4970,7 @@
                       </a:pPr>
                       <a:r>
                         <a:rPr/>
-                        <a:t>First Draft of Research Topic / Research Question</a:t>
+                        <a:t>1 Research topic and question</a:t>
                       </a:r>
                     </a:p>
                   </a:txBody>
@@ -5116,7 +5009,7 @@
                       </a:pPr>
                       <a:r>
                         <a:rPr/>
-                        <a:t>Academic Audiences and Techniques of Persuasion</a:t>
+                        <a:t>Oct 26</a:t>
                       </a:r>
                     </a:p>
                   </a:txBody>
@@ -5132,7 +5025,7 @@
                       </a:pPr>
                       <a:r>
                         <a:rPr/>
-                        <a:t>Where’s the Gap? Mapping a Field</a:t>
+                        <a:t>Article anatomy, review design and mapping a field</a:t>
                       </a:r>
                     </a:p>
                   </a:txBody>
@@ -5148,7 +5041,7 @@
                       </a:pPr>
                       <a:r>
                         <a:rPr/>
-                        <a:t>Design, Method and Structure of the Literature Review</a:t>
+                        <a:t>2 Review design method and scope</a:t>
                       </a:r>
                     </a:p>
                   </a:txBody>
@@ -5187,7 +5080,7 @@
                       </a:pPr>
                       <a:r>
                         <a:rPr/>
-                        <a:t>Does Artificial Intelligence Mean Artificial Knowledge? How AI is Impacting Academia</a:t>
+                        <a:t>Nov 2</a:t>
                       </a:r>
                     </a:p>
                   </a:txBody>
@@ -5203,7 +5096,7 @@
                       </a:pPr>
                       <a:r>
                         <a:rPr/>
-                        <a:t>Vibe Scholarship (Is It as Bad as It Sounds?)</a:t>
+                        <a:t>AI-assisted close and distant reading</a:t>
                       </a:r>
                     </a:p>
                   </a:txBody>
@@ -5219,7 +5112,7 @@
                       </a:pPr>
                       <a:r>
                         <a:rPr/>
-                        <a:t>Concept Map of the Literature</a:t>
+                        <a:t>3 Conceptual map of the literature</a:t>
                       </a:r>
                     </a:p>
                   </a:txBody>
@@ -5258,7 +5151,7 @@
                       </a:pPr>
                       <a:r>
                         <a:rPr/>
-                        <a:t>Finding Your Scholarly Voice: Peers / Audience / Venue / Field</a:t>
+                        <a:t>Nov 9</a:t>
                       </a:r>
                     </a:p>
                   </a:txBody>
@@ -5274,23 +5167,23 @@
                       </a:pPr>
                       <a:r>
                         <a:rPr/>
-                        <a:t>Drafting a section of your review in a </a:t>
+                        <a:t>Difficult texts, audiences and scholarly voice</a:t>
                       </a:r>
                       <a:r>
                         <a:rPr i="1"/>
-                        <a:t>scientific</a:t>
+                        <a:t/>
                       </a:r>
                       <a:r>
                         <a:rPr/>
-                        <a:t> and </a:t>
+                        <a:t/>
                       </a:r>
                       <a:r>
                         <a:rPr i="1"/>
-                        <a:t>humanities</a:t>
+                        <a:t/>
                       </a:r>
                       <a:r>
                         <a:rPr/>
-                        <a:t> mode</a:t>
+                        <a:t/>
                       </a:r>
                     </a:p>
                   </a:txBody>
@@ -5306,7 +5199,7 @@
                       </a:pPr>
                       <a:r>
                         <a:rPr/>
-                        <a:t>Literature Review Sample: In the Scientific Mode</a:t>
+                        <a:t>4 Literature review writing sample</a:t>
                       </a:r>
                     </a:p>
                   </a:txBody>
@@ -5345,7 +5238,7 @@
                       </a:pPr>
                       <a:r>
                         <a:rPr/>
-                        <a:t>“What Do I Know?” Towards A Sociology of Knowledge</a:t>
+                        <a:t>Nov 16</a:t>
                       </a:r>
                     </a:p>
                   </a:txBody>
@@ -5361,7 +5254,7 @@
                       </a:pPr>
                       <a:r>
                         <a:rPr/>
-                        <a:t>Framing Language: “Carry” Your Reader</a:t>
+                        <a:t>Structure, signposting and scholarly communities</a:t>
                       </a:r>
                     </a:p>
                   </a:txBody>
@@ -5377,7 +5270,7 @@
                       </a:pPr>
                       <a:r>
                         <a:rPr/>
-                        <a:t>Frame up your Literature Review</a:t>
+                        <a:t>5 Structured draft and signposting</a:t>
                       </a:r>
                     </a:p>
                   </a:txBody>
@@ -5416,7 +5309,7 @@
                       </a:pPr>
                       <a:r>
                         <a:rPr/>
-                        <a:t>The Reflexive Researcher and Interpreting Scholarship</a:t>
+                        <a:t>Nov 30</a:t>
                       </a:r>
                     </a:p>
                   </a:txBody>
@@ -5432,7 +5325,7 @@
                       </a:pPr>
                       <a:r>
                         <a:rPr/>
-                        <a:t>Reflecting on your positionality vis-a-vis interpretation; drafting a statement about AI’s epistemic role</a:t>
+                        <a:t>Reflexivity, positionality and AI in scholarship</a:t>
                       </a:r>
                     </a:p>
                   </a:txBody>
@@ -5448,7 +5341,7 @@
                       </a:pPr>
                       <a:r>
                         <a:rPr/>
-                        <a:t>Statement on the Use of AI in Your Literature Review / Reflection on the Role of AI in Academia</a:t>
+                        <a:t>6 AI-use statement and reflexive commentary</a:t>
                       </a:r>
                     </a:p>
                   </a:txBody>
@@ -5487,7 +5380,7 @@
                       </a:pPr>
                       <a:r>
                         <a:rPr/>
-                        <a:t>The Automatic Academy? The Future of Scholarship</a:t>
+                        <a:t>Dec 7</a:t>
                       </a:r>
                     </a:p>
                   </a:txBody>
@@ -5503,7 +5396,7 @@
                       </a:pPr>
                       <a:r>
                         <a:rPr/>
-                        <a:t>Compiling a complete literature review</a:t>
+                        <a:t>Future of scholarship; final review workshop</a:t>
                       </a:r>
                     </a:p>
                   </a:txBody>
@@ -5519,7 +5412,7 @@
                       </a:pPr>
                       <a:r>
                         <a:rPr dirty="0"/>
-                        <a:t>Final Literature Review</a:t>
+                        <a:t>7 Final literature review (Tue Dec 15)</a:t>
                       </a:r>
                     </a:p>
                   </a:txBody>
@@ -5583,104 +5476,89 @@
             </a:pPr>
             <a:r>
               <a:rPr b="1"/>
-              <a:t>Rubric / Criteria</a:t>
-            </a:r>
-          </a:p>
-          <a:p>
-            <a:pPr lvl="0"/>
+              <a:t>Assessment criteria</a:t>
+            </a:r>
+          </a:p>
+          <a:p>
+            <a:pPr lvl="0"/>
+            <a:r>
+              <a:rPr b="0"/>
+              <a:t>Significance and feasibility of the question</a:t>
+            </a:r>
+            <a:r>
+              <a:rPr/>
+              <a:t/>
+            </a:r>
+          </a:p>
+          <a:p>
+            <a:pPr lvl="0"/>
+            <a:r>
+              <a:rPr b="0"/>
+              <a:t>Relevance and traceability of sources</a:t>
+            </a:r>
+            <a:r>
+              <a:rPr/>
+              <a:t/>
+            </a:r>
+          </a:p>
+          <a:p>
+            <a:pPr lvl="0"/>
+            <a:r>
+              <a:rPr b="0"/>
+              <a:t>Quality of interpretation and synthesis</a:t>
+            </a:r>
+            <a:r>
+              <a:rPr/>
+              <a:t/>
+            </a:r>
             <a:r>
               <a:rPr b="1"/>
-              <a:t>Develop</a:t>
-            </a:r>
-            <a:r>
-              <a:rPr/>
-              <a:t> novel, significant and feasible research question</a:t>
-            </a:r>
-          </a:p>
-          <a:p>
-            <a:pPr lvl="0"/>
+              <a:t/>
+            </a:r>
+            <a:r>
+              <a:rPr/>
+              <a:t/>
+            </a:r>
+          </a:p>
+          <a:p>
+            <a:pPr lvl="0"/>
+            <a:r>
+              <a:rPr b="0"/>
+              <a:t>Clarity of organization, framing and scholarly voice</a:t>
+            </a:r>
+            <a:r>
+              <a:rPr/>
+              <a:t/>
+            </a:r>
+          </a:p>
+          <a:p>
+            <a:pPr lvl="0"/>
+            <a:r>
+              <a:rPr b="0"/>
+              <a:t>Reflexivity and responsible, transparent AI use</a:t>
+            </a:r>
+            <a:r>
+              <a:rPr/>
+              <a:t/>
+            </a:r>
+          </a:p>
+          <a:p>
+            <a:pPr lvl="0"/>
+            <a:r>
+              <a:rPr b="0"/>
+              <a:t>Responsiveness to evidence and feedback</a:t>
+            </a:r>
+            <a:r>
+              <a:rPr/>
+              <a:t/>
+            </a:r>
             <a:r>
               <a:rPr b="1"/>
-              <a:t>Compile</a:t>
-            </a:r>
-            <a:r>
-              <a:rPr/>
-              <a:t> relevant map of the field relating to the research question</a:t>
-            </a:r>
-          </a:p>
-          <a:p>
-            <a:pPr lvl="0"/>
-            <a:r>
-              <a:rPr b="1"/>
-              <a:t>Choose</a:t>
-            </a:r>
-            <a:r>
-              <a:rPr/>
-              <a:t> and </a:t>
-            </a:r>
-            <a:r>
-              <a:rPr b="1"/>
-              <a:t>apply</a:t>
-            </a:r>
-            <a:r>
-              <a:rPr/>
-              <a:t> appropriate citation practices (science / humanities / mix) for question &amp; field</a:t>
-            </a:r>
-          </a:p>
-          <a:p>
-            <a:pPr lvl="0"/>
-            <a:r>
-              <a:rPr b="1"/>
-              <a:t>Use</a:t>
-            </a:r>
-            <a:r>
-              <a:rPr/>
-              <a:t> framing / signposting / metadiscursive language</a:t>
-            </a:r>
-          </a:p>
-          <a:p>
-            <a:pPr lvl="0"/>
-            <a:r>
-              <a:rPr b="1"/>
-              <a:t>Show</a:t>
-            </a:r>
-            <a:r>
-              <a:rPr/>
-              <a:t> reflexivity as a scholar</a:t>
-            </a:r>
-          </a:p>
-          <a:p>
-            <a:pPr lvl="0"/>
-            <a:r>
-              <a:rPr b="1"/>
-              <a:t>Acknowledge</a:t>
-            </a:r>
-            <a:r>
-              <a:rPr/>
-              <a:t> and </a:t>
-            </a:r>
-            <a:r>
-              <a:rPr b="1"/>
-              <a:t>demonstrate</a:t>
-            </a:r>
-            <a:r>
-              <a:rPr/>
-              <a:t> appropriate use of AI</a:t>
-            </a:r>
-          </a:p>
-          <a:p>
-            <a:pPr lvl="0"/>
-            <a:r>
-              <a:rPr/>
-              <a:t>Use all of the above to </a:t>
-            </a:r>
-            <a:r>
-              <a:rPr b="1"/>
-              <a:t>highlight</a:t>
-            </a:r>
-            <a:r>
-              <a:rPr/>
-              <a:t> a plausible gap in the literature</a:t>
+              <a:t/>
+            </a:r>
+            <a:r>
+              <a:rPr/>
+              <a:t/>
             </a:r>
           </a:p>
         </p:txBody>

</xml_diff>